<commit_message>
Minor corrections to W1S3, W4S3, W8S2, W8S3.
</commit_message>
<xml_diff>
--- a/W4/3. W4S3 final/W4S3.pptx
+++ b/W4/3. W4S3 final/W4S3.pptx
@@ -323,10 +323,25 @@
   <pc:docChgLst>
     <pc:chgData name="Matthieu De Mari" userId="dfb708c9-d8dc-439f-9a3b-c772bf4a311c" providerId="ADAL" clId="{81E9B007-0C2C-493E-9B93-55A62C9C1F12}"/>
     <pc:docChg chg="undo custSel addSld delSld modSld sldOrd modSection">
-      <pc:chgData name="Matthieu De Mari" userId="dfb708c9-d8dc-439f-9a3b-c772bf4a311c" providerId="ADAL" clId="{81E9B007-0C2C-493E-9B93-55A62C9C1F12}" dt="2026-03-03T10:58:19.174" v="2187" actId="20577"/>
+      <pc:chgData name="Matthieu De Mari" userId="dfb708c9-d8dc-439f-9a3b-c772bf4a311c" providerId="ADAL" clId="{81E9B007-0C2C-493E-9B93-55A62C9C1F12}" dt="2026-03-15T14:53:47.264" v="2215" actId="20577"/>
       <pc:docMkLst>
         <pc:docMk/>
       </pc:docMkLst>
+      <pc:sldChg chg="modSp mod">
+        <pc:chgData name="Matthieu De Mari" userId="dfb708c9-d8dc-439f-9a3b-c772bf4a311c" providerId="ADAL" clId="{81E9B007-0C2C-493E-9B93-55A62C9C1F12}" dt="2026-03-15T14:53:47.264" v="2215" actId="20577"/>
+        <pc:sldMkLst>
+          <pc:docMk/>
+          <pc:sldMk cId="1036081419" sldId="346"/>
+        </pc:sldMkLst>
+        <pc:spChg chg="mod">
+          <ac:chgData name="Matthieu De Mari" userId="dfb708c9-d8dc-439f-9a3b-c772bf4a311c" providerId="ADAL" clId="{81E9B007-0C2C-493E-9B93-55A62C9C1F12}" dt="2026-03-15T14:53:47.264" v="2215" actId="20577"/>
+          <ac:spMkLst>
+            <pc:docMk/>
+            <pc:sldMk cId="1036081419" sldId="346"/>
+            <ac:spMk id="4" creationId="{7E420A50-DCDA-4FEF-986F-775F53063E3A}"/>
+          </ac:spMkLst>
+        </pc:spChg>
+      </pc:sldChg>
       <pc:sldChg chg="modSp mod">
         <pc:chgData name="Matthieu De Mari" userId="dfb708c9-d8dc-439f-9a3b-c772bf4a311c" providerId="ADAL" clId="{81E9B007-0C2C-493E-9B93-55A62C9C1F12}" dt="2026-02-18T12:13:35.291" v="1424" actId="20577"/>
         <pc:sldMkLst>
@@ -622,14 +637,6 @@
             <ac:spMk id="4" creationId="{76E28ACE-9F17-186D-BD8A-ADCED80C3ADF}"/>
           </ac:spMkLst>
         </pc:spChg>
-        <pc:picChg chg="del">
-          <ac:chgData name="Matthieu De Mari" userId="dfb708c9-d8dc-439f-9a3b-c772bf4a311c" providerId="ADAL" clId="{81E9B007-0C2C-493E-9B93-55A62C9C1F12}" dt="2026-03-03T10:43:12.060" v="1449" actId="478"/>
-          <ac:picMkLst>
-            <pc:docMk/>
-            <pc:sldMk cId="622754831" sldId="627"/>
-            <ac:picMk id="8" creationId="{3643E417-DD86-D969-F75D-BD91E5DC4087}"/>
-          </ac:picMkLst>
-        </pc:picChg>
       </pc:sldChg>
       <pc:sldChg chg="addSp delSp modSp add mod chgLayout">
         <pc:chgData name="Matthieu De Mari" userId="dfb708c9-d8dc-439f-9a3b-c772bf4a311c" providerId="ADAL" clId="{81E9B007-0C2C-493E-9B93-55A62C9C1F12}" dt="2026-03-03T10:44:50.545" v="1493" actId="20577"/>
@@ -661,14 +668,6 @@
             <ac:spMk id="4" creationId="{38AEBE44-9AA0-0BD2-9DC3-65317E2DDB4F}"/>
           </ac:spMkLst>
         </pc:spChg>
-        <pc:picChg chg="del">
-          <ac:chgData name="Matthieu De Mari" userId="dfb708c9-d8dc-439f-9a3b-c772bf4a311c" providerId="ADAL" clId="{81E9B007-0C2C-493E-9B93-55A62C9C1F12}" dt="2026-03-03T10:44:11.775" v="1455" actId="478"/>
-          <ac:picMkLst>
-            <pc:docMk/>
-            <pc:sldMk cId="618793995" sldId="628"/>
-            <ac:picMk id="7" creationId="{9AC78AEE-88FF-E204-0618-9A70BC84D55B}"/>
-          </ac:picMkLst>
-        </pc:picChg>
       </pc:sldChg>
       <pc:sldChg chg="modSp add mod">
         <pc:chgData name="Matthieu De Mari" userId="dfb708c9-d8dc-439f-9a3b-c772bf4a311c" providerId="ADAL" clId="{81E9B007-0C2C-493E-9B93-55A62C9C1F12}" dt="2026-03-03T10:56:56.031" v="2062" actId="27636"/>
@@ -787,7 +786,7 @@
           <a:p>
             <a:fld id="{61478373-EB31-4867-8CF0-FA31364748A5}" type="datetimeFigureOut">
               <a:rPr lang="en-GB" smtClean="0"/>
-              <a:t>03/03/2026</a:t>
+              <a:t>15/03/2026</a:t>
             </a:fld>
             <a:endParaRPr lang="en-GB"/>
           </a:p>
@@ -1204,7 +1203,7 @@
           <a:p>
             <a:fld id="{E85DF616-B21E-4EF6-A6A5-95E2FB3EB1A1}" type="datetimeFigureOut">
               <a:rPr lang="en-GB" smtClean="0"/>
-              <a:t>03/03/2026</a:t>
+              <a:t>15/03/2026</a:t>
             </a:fld>
             <a:endParaRPr lang="en-GB"/>
           </a:p>
@@ -1404,7 +1403,7 @@
           <a:p>
             <a:fld id="{E85DF616-B21E-4EF6-A6A5-95E2FB3EB1A1}" type="datetimeFigureOut">
               <a:rPr lang="en-GB" smtClean="0"/>
-              <a:t>03/03/2026</a:t>
+              <a:t>15/03/2026</a:t>
             </a:fld>
             <a:endParaRPr lang="en-GB"/>
           </a:p>
@@ -1614,7 +1613,7 @@
           <a:p>
             <a:fld id="{E85DF616-B21E-4EF6-A6A5-95E2FB3EB1A1}" type="datetimeFigureOut">
               <a:rPr lang="en-GB" smtClean="0"/>
-              <a:t>03/03/2026</a:t>
+              <a:t>15/03/2026</a:t>
             </a:fld>
             <a:endParaRPr lang="en-GB"/>
           </a:p>
@@ -1814,7 +1813,7 @@
           <a:p>
             <a:fld id="{E85DF616-B21E-4EF6-A6A5-95E2FB3EB1A1}" type="datetimeFigureOut">
               <a:rPr lang="en-GB" smtClean="0"/>
-              <a:t>03/03/2026</a:t>
+              <a:t>15/03/2026</a:t>
             </a:fld>
             <a:endParaRPr lang="en-GB"/>
           </a:p>
@@ -2090,7 +2089,7 @@
           <a:p>
             <a:fld id="{E85DF616-B21E-4EF6-A6A5-95E2FB3EB1A1}" type="datetimeFigureOut">
               <a:rPr lang="en-GB" smtClean="0"/>
-              <a:t>03/03/2026</a:t>
+              <a:t>15/03/2026</a:t>
             </a:fld>
             <a:endParaRPr lang="en-GB"/>
           </a:p>
@@ -2358,7 +2357,7 @@
           <a:p>
             <a:fld id="{E85DF616-B21E-4EF6-A6A5-95E2FB3EB1A1}" type="datetimeFigureOut">
               <a:rPr lang="en-GB" smtClean="0"/>
-              <a:t>03/03/2026</a:t>
+              <a:t>15/03/2026</a:t>
             </a:fld>
             <a:endParaRPr lang="en-GB"/>
           </a:p>
@@ -2773,7 +2772,7 @@
           <a:p>
             <a:fld id="{E85DF616-B21E-4EF6-A6A5-95E2FB3EB1A1}" type="datetimeFigureOut">
               <a:rPr lang="en-GB" smtClean="0"/>
-              <a:t>03/03/2026</a:t>
+              <a:t>15/03/2026</a:t>
             </a:fld>
             <a:endParaRPr lang="en-GB"/>
           </a:p>
@@ -2915,7 +2914,7 @@
           <a:p>
             <a:fld id="{E85DF616-B21E-4EF6-A6A5-95E2FB3EB1A1}" type="datetimeFigureOut">
               <a:rPr lang="en-GB" smtClean="0"/>
-              <a:t>03/03/2026</a:t>
+              <a:t>15/03/2026</a:t>
             </a:fld>
             <a:endParaRPr lang="en-GB"/>
           </a:p>
@@ -3028,7 +3027,7 @@
           <a:p>
             <a:fld id="{E85DF616-B21E-4EF6-A6A5-95E2FB3EB1A1}" type="datetimeFigureOut">
               <a:rPr lang="en-GB" smtClean="0"/>
-              <a:t>03/03/2026</a:t>
+              <a:t>15/03/2026</a:t>
             </a:fld>
             <a:endParaRPr lang="en-GB"/>
           </a:p>
@@ -3341,7 +3340,7 @@
           <a:p>
             <a:fld id="{E85DF616-B21E-4EF6-A6A5-95E2FB3EB1A1}" type="datetimeFigureOut">
               <a:rPr lang="en-GB" smtClean="0"/>
-              <a:t>03/03/2026</a:t>
+              <a:t>15/03/2026</a:t>
             </a:fld>
             <a:endParaRPr lang="en-GB"/>
           </a:p>
@@ -3630,7 +3629,7 @@
           <a:p>
             <a:fld id="{E85DF616-B21E-4EF6-A6A5-95E2FB3EB1A1}" type="datetimeFigureOut">
               <a:rPr lang="en-GB" smtClean="0"/>
-              <a:t>03/03/2026</a:t>
+              <a:t>15/03/2026</a:t>
             </a:fld>
             <a:endParaRPr lang="en-GB"/>
           </a:p>
@@ -3873,7 +3872,7 @@
           <a:p>
             <a:fld id="{E85DF616-B21E-4EF6-A6A5-95E2FB3EB1A1}" type="datetimeFigureOut">
               <a:rPr lang="en-GB" smtClean="0"/>
-              <a:t>03/03/2026</a:t>
+              <a:t>15/03/2026</a:t>
             </a:fld>
             <a:endParaRPr lang="en-GB"/>
           </a:p>
@@ -11933,8 +11932,8 @@
           </a:p>
         </p:txBody>
       </p:sp>
-      <mc:AlternateContent xmlns:mc="http://schemas.openxmlformats.org/markup-compatibility/2006">
-        <mc:Choice xmlns:a14="http://schemas.microsoft.com/office/drawing/2010/main" Requires="a14">
+      <mc:AlternateContent xmlns:mc="http://schemas.openxmlformats.org/markup-compatibility/2006" xmlns:a14="http://schemas.microsoft.com/office/drawing/2010/main">
+        <mc:Choice Requires="a14">
           <p:sp>
             <p:nvSpPr>
               <p:cNvPr id="4" name="Content Placeholder 3">
@@ -12016,55 +12015,75 @@
                 <a14:m>
                   <m:oMath xmlns:m="http://schemas.openxmlformats.org/officeDocument/2006/math">
                     <m:r>
-                      <a:rPr lang="en-GB" i="1"/>
+                      <a:rPr lang="en-GB" i="1">
+                        <a:latin typeface="Cambria Math" panose="02040503050406030204" pitchFamily="18" charset="0"/>
+                      </a:rPr>
                       <m:t>𝐿</m:t>
                     </m:r>
                     <m:r>
-                      <a:rPr lang="en-GB"/>
+                      <a:rPr lang="en-GB">
+                        <a:latin typeface="Cambria Math" panose="02040503050406030204" pitchFamily="18" charset="0"/>
+                      </a:rPr>
                       <m:t>=</m:t>
                     </m:r>
                     <m:sSub>
                       <m:sSubPr>
                         <m:ctrlPr>
-                          <a:rPr lang="ar-AE" i="1"/>
+                          <a:rPr lang="ar-AE" i="1">
+                            <a:latin typeface="Cambria Math" panose="02040503050406030204" pitchFamily="18" charset="0"/>
+                          </a:rPr>
                         </m:ctrlPr>
                       </m:sSubPr>
                       <m:e>
                         <m:r>
-                          <a:rPr lang="ar-AE" i="1"/>
+                          <a:rPr lang="ar-AE" i="1">
+                            <a:latin typeface="Cambria Math" panose="02040503050406030204" pitchFamily="18" charset="0"/>
+                          </a:rPr>
                           <m:t>𝐿</m:t>
                         </m:r>
                       </m:e>
                       <m:sub>
                         <m:r>
-                          <a:rPr lang="ar-AE" i="1"/>
+                          <a:rPr lang="ar-AE" i="1">
+                            <a:latin typeface="Cambria Math" panose="02040503050406030204" pitchFamily="18" charset="0"/>
+                          </a:rPr>
                           <m:t>𝑚𝑎𝑖𝑛</m:t>
                         </m:r>
                       </m:sub>
                     </m:sSub>
                     <m:r>
-                      <a:rPr lang="ar-AE"/>
+                      <a:rPr lang="ar-AE">
+                        <a:latin typeface="Cambria Math" panose="02040503050406030204" pitchFamily="18" charset="0"/>
+                      </a:rPr>
                       <m:t>+</m:t>
                     </m:r>
                     <m:r>
-                      <a:rPr lang="ar-AE" i="1"/>
+                      <a:rPr lang="ar-AE" i="1">
+                        <a:latin typeface="Cambria Math" panose="02040503050406030204" pitchFamily="18" charset="0"/>
+                      </a:rPr>
                       <m:t>𝛼</m:t>
                     </m:r>
                     <m:sSub>
                       <m:sSubPr>
                         <m:ctrlPr>
-                          <a:rPr lang="ar-AE" i="1"/>
+                          <a:rPr lang="ar-AE" i="1">
+                            <a:latin typeface="Cambria Math" panose="02040503050406030204" pitchFamily="18" charset="0"/>
+                          </a:rPr>
                         </m:ctrlPr>
                       </m:sSubPr>
                       <m:e>
                         <m:r>
-                          <a:rPr lang="ar-AE" i="1"/>
+                          <a:rPr lang="ar-AE" i="1">
+                            <a:latin typeface="Cambria Math" panose="02040503050406030204" pitchFamily="18" charset="0"/>
+                          </a:rPr>
                           <m:t>𝐿</m:t>
                         </m:r>
                       </m:e>
                       <m:sub>
                         <m:r>
-                          <a:rPr lang="ar-AE" i="1"/>
+                          <a:rPr lang="ar-AE" i="1">
+                            <a:latin typeface="Cambria Math" panose="02040503050406030204" pitchFamily="18" charset="0"/>
+                          </a:rPr>
                           <m:t>𝑎𝑢𝑥</m:t>
                         </m:r>
                       </m:sub>
@@ -12106,7 +12125,7 @@
             </p:txBody>
           </p:sp>
         </mc:Choice>
-        <mc:Fallback>
+        <mc:Fallback xmlns="">
           <p:sp>
             <p:nvSpPr>
               <p:cNvPr id="4" name="Content Placeholder 3">
@@ -12710,8 +12729,8 @@
           </a:p>
         </p:txBody>
       </p:sp>
-      <mc:AlternateContent xmlns:mc="http://schemas.openxmlformats.org/markup-compatibility/2006">
-        <mc:Choice xmlns:a14="http://schemas.microsoft.com/office/drawing/2010/main" Requires="a14">
+      <mc:AlternateContent xmlns:mc="http://schemas.openxmlformats.org/markup-compatibility/2006" xmlns:a14="http://schemas.microsoft.com/office/drawing/2010/main">
+        <mc:Choice Requires="a14">
           <p:sp>
             <p:nvSpPr>
               <p:cNvPr id="3" name="Content Placeholder 2">
@@ -12750,7 +12769,9 @@
                 <a14:m>
                   <m:oMath xmlns:m="http://schemas.openxmlformats.org/officeDocument/2006/math">
                     <m:r>
-                      <a:rPr lang="en-GB" i="1"/>
+                      <a:rPr lang="en-GB" i="1">
+                        <a:latin typeface="Cambria Math" panose="02040503050406030204" pitchFamily="18" charset="0"/>
+                      </a:rPr>
                       <m:t>𝜙</m:t>
                     </m:r>
                   </m:oMath>
@@ -12771,30 +12792,40 @@
                       <m:t>depth</m:t>
                     </m:r>
                     <m:r>
-                      <a:rPr lang="en-GB"/>
+                      <a:rPr lang="en-GB">
+                        <a:latin typeface="Cambria Math" panose="02040503050406030204" pitchFamily="18" charset="0"/>
+                      </a:rPr>
                       <m:t>=</m:t>
                     </m:r>
                     <m:sSup>
                       <m:sSupPr>
                         <m:ctrlPr>
-                          <a:rPr lang="ar-AE" i="1"/>
+                          <a:rPr lang="ar-AE" i="1">
+                            <a:latin typeface="Cambria Math" panose="02040503050406030204" pitchFamily="18" charset="0"/>
+                          </a:rPr>
                         </m:ctrlPr>
                       </m:sSupPr>
                       <m:e>
                         <m:r>
-                          <a:rPr lang="ar-AE" i="1"/>
+                          <a:rPr lang="ar-AE" i="1">
+                            <a:latin typeface="Cambria Math" panose="02040503050406030204" pitchFamily="18" charset="0"/>
+                          </a:rPr>
                           <m:t>𝛼</m:t>
                         </m:r>
                       </m:e>
                       <m:sup>
                         <m:r>
-                          <a:rPr lang="ar-AE" i="1"/>
+                          <a:rPr lang="ar-AE" i="1">
+                            <a:latin typeface="Cambria Math" panose="02040503050406030204" pitchFamily="18" charset="0"/>
+                          </a:rPr>
                           <m:t>𝜙</m:t>
                         </m:r>
                       </m:sup>
                     </m:sSup>
                     <m:r>
-                      <a:rPr lang="ar-AE"/>
+                      <a:rPr lang="ar-AE">
+                        <a:latin typeface="Cambria Math" panose="02040503050406030204" pitchFamily="18" charset="0"/>
+                      </a:rPr>
                       <m:t>, </m:t>
                     </m:r>
                     <m:r>
@@ -12805,30 +12836,40 @@
                       <m:t>width</m:t>
                     </m:r>
                     <m:r>
-                      <a:rPr lang="en-GB"/>
+                      <a:rPr lang="en-GB">
+                        <a:latin typeface="Cambria Math" panose="02040503050406030204" pitchFamily="18" charset="0"/>
+                      </a:rPr>
                       <m:t>=</m:t>
                     </m:r>
                     <m:sSup>
                       <m:sSupPr>
                         <m:ctrlPr>
-                          <a:rPr lang="ar-AE" i="1"/>
+                          <a:rPr lang="ar-AE" i="1">
+                            <a:latin typeface="Cambria Math" panose="02040503050406030204" pitchFamily="18" charset="0"/>
+                          </a:rPr>
                         </m:ctrlPr>
                       </m:sSupPr>
                       <m:e>
                         <m:r>
-                          <a:rPr lang="ar-AE" i="1"/>
+                          <a:rPr lang="ar-AE" i="1">
+                            <a:latin typeface="Cambria Math" panose="02040503050406030204" pitchFamily="18" charset="0"/>
+                          </a:rPr>
                           <m:t>𝛽</m:t>
                         </m:r>
                       </m:e>
                       <m:sup>
                         <m:r>
-                          <a:rPr lang="ar-AE" i="1"/>
+                          <a:rPr lang="ar-AE" i="1">
+                            <a:latin typeface="Cambria Math" panose="02040503050406030204" pitchFamily="18" charset="0"/>
+                          </a:rPr>
                           <m:t>𝜙</m:t>
                         </m:r>
                       </m:sup>
                     </m:sSup>
                     <m:r>
-                      <a:rPr lang="ar-AE"/>
+                      <a:rPr lang="ar-AE">
+                        <a:latin typeface="Cambria Math" panose="02040503050406030204" pitchFamily="18" charset="0"/>
+                      </a:rPr>
                       <m:t>, </m:t>
                     </m:r>
                     <m:r>
@@ -12839,24 +12880,32 @@
                       <m:t>resolution</m:t>
                     </m:r>
                     <m:r>
-                      <a:rPr lang="en-GB"/>
+                      <a:rPr lang="en-GB">
+                        <a:latin typeface="Cambria Math" panose="02040503050406030204" pitchFamily="18" charset="0"/>
+                      </a:rPr>
                       <m:t>=</m:t>
                     </m:r>
                     <m:sSup>
                       <m:sSupPr>
                         <m:ctrlPr>
-                          <a:rPr lang="ar-AE" i="1"/>
+                          <a:rPr lang="ar-AE" i="1">
+                            <a:latin typeface="Cambria Math" panose="02040503050406030204" pitchFamily="18" charset="0"/>
+                          </a:rPr>
                         </m:ctrlPr>
                       </m:sSupPr>
                       <m:e>
                         <m:r>
-                          <a:rPr lang="ar-AE" i="1"/>
+                          <a:rPr lang="ar-AE" i="1">
+                            <a:latin typeface="Cambria Math" panose="02040503050406030204" pitchFamily="18" charset="0"/>
+                          </a:rPr>
                           <m:t>𝛾</m:t>
                         </m:r>
                       </m:e>
                       <m:sup>
                         <m:r>
-                          <a:rPr lang="ar-AE" i="1"/>
+                          <a:rPr lang="ar-AE" i="1">
+                            <a:latin typeface="Cambria Math" panose="02040503050406030204" pitchFamily="18" charset="0"/>
+                          </a:rPr>
                           <m:t>𝜙</m:t>
                         </m:r>
                       </m:sup>
@@ -12976,7 +13025,9 @@
                 <a14:m>
                   <m:oMath xmlns:m="http://schemas.openxmlformats.org/officeDocument/2006/math">
                     <m:r>
-                      <a:rPr lang="en-GB" i="1"/>
+                      <a:rPr lang="en-GB" i="1">
+                        <a:latin typeface="Cambria Math" panose="02040503050406030204" pitchFamily="18" charset="0"/>
+                      </a:rPr>
                       <m:t>𝜙</m:t>
                     </m:r>
                   </m:oMath>
@@ -13045,7 +13096,7 @@
             </p:txBody>
           </p:sp>
         </mc:Choice>
-        <mc:Fallback>
+        <mc:Fallback xmlns="">
           <p:sp>
             <p:nvSpPr>
               <p:cNvPr id="3" name="Content Placeholder 2">
@@ -16502,7 +16553,15 @@
           <a:p>
             <a:r>
               <a:rPr lang="en-US" dirty="0"/>
-              <a:t>Some milestone models and their key ideas (residuals, parallelizing, dynamic scaling, etc.)</a:t>
+              <a:t>Some milestone models and their key ideas (residuals, parallelizing/inception, </a:t>
+            </a:r>
+            <a:r>
+              <a:rPr lang="en-US"/>
+              <a:t>multiple outputs, dynamic </a:t>
+            </a:r>
+            <a:r>
+              <a:rPr lang="en-US" dirty="0"/>
+              <a:t>scaling, etc.)</a:t>
             </a:r>
           </a:p>
           <a:p>

</xml_diff>